<commit_message>
Session 3: fix cover-slide notes; regenerate script page
Co-Authored-By: Claude Opus 5.5 <noreply@anthropic.com>
</commit_message>
<xml_diff>
--- a/session-3/AEPA-Session-3.pptx
+++ b/session-3/AEPA-Session-3.pptx
@@ -124,38 +124,38 @@
   <p:extLst>
     <p:ext uri="{521415D9-36F7-43E2-AB2F-B90AF26B5E84}">
       <p14:sectionLst xmlns:p14="http://schemas.microsoft.com/office/powerpoint/2010/main">
-        <p14:section name="Intro" id="{88793b11-0cb4-0bd7-0795-8845d5ad4250}">
+        <p14:section name="Intro" id="{ed49f4a8-7f90-417d-3895-ba2b549c9515}">
           <p14:sldIdLst>
             <p14:sldId id="256"/>
             <p14:sldId id="257"/>
             <p14:sldId id="258"/>
           </p14:sldIdLst>
         </p14:section>
-        <p14:section name="How models are trained" id="{d4ab561a-d086-48ed-cf80-de4f045e916a}">
+        <p14:section name="How models are trained" id="{bd7269f6-331c-f715-01b9-965b4f54d487}">
           <p14:sldIdLst>
             <p14:sldId id="259"/>
             <p14:sldId id="260"/>
           </p14:sldIdLst>
         </p14:section>
-        <p14:section name="Station 1: Train a model" id="{42a0d29f-8bc7-7075-0b03-00473b8fd1a9}">
+        <p14:section name="Station 1: Train a model" id="{313a47e2-0d96-3d33-21f7-466d1d25514e}">
           <p14:sldIdLst>
             <p14:sldId id="261"/>
             <p14:sldId id="262"/>
           </p14:sldIdLst>
         </p14:section>
-        <p14:section name="Station 2: Map meaning" id="{12859551-558d-538b-1fdb-cf384d449f8b}">
+        <p14:section name="Station 2: Map meaning" id="{7b0c9ed1-82b4-9425-fc33-02cee6e025a0}">
           <p14:sldIdLst>
             <p14:sldId id="263"/>
             <p14:sldId id="264"/>
           </p14:sldIdLst>
         </p14:section>
-        <p14:section name="Station 3: Noise to image" id="{f16620ef-df93-71dc-2a0d-18fad8bef874}">
+        <p14:section name="Station 3: Noise to image" id="{6df41c92-0067-fc8e-4d9c-ea8d563e2749}">
           <p14:sldIdLst>
             <p14:sldId id="265"/>
             <p14:sldId id="266"/>
           </p14:sldIdLst>
         </p14:section>
-        <p14:section name="Agents and security" id="{28c8485c-11a0-7643-c32e-68c4f0de8db8}">
+        <p14:section name="Agents and security" id="{0f996dc1-7cc4-8e7a-28dc-e2b73f158a96}">
           <p14:sldIdLst>
             <p14:sldId id="267"/>
             <p14:sldId id="268"/>
@@ -163,7 +163,7 @@
             <p14:sldId id="270"/>
           </p14:sldIdLst>
         </p14:section>
-        <p14:section name="Wrap-up" id="{93880a56-8564-11bd-c9ce-2957e73589a8}">
+        <p14:section name="Wrap-up" id="{f2a1014e-bd57-f107-398b-db83c9a91c3f}">
           <p14:sldIdLst>
             <p14:sldId id="271"/>
             <p14:sldId id="272"/>
@@ -575,7 +575,9 @@
             <a:r>
               <a:rPr lang="en-US" dirty="0"/>
               <a:t>[~1:00]
-За, сайн байцгаана уу залуусаа! AEPA-гийн 3-р хичээлд тавтай морил.,Өмнөх хоёр хичээлээр бид AI-г яаж ашиглах, яаж боддогийг үзсэн. Өнөөдөр бол бүр дотор нь орно. AI яаж бүтдэг вэ гэдгийг яриад өнгөрөхгүй, гараараа хийж үзнэ.,Өнөөдөр лекц бага, дасгал их. Дөрвөн станц бий: AI сургах, утгын газрын зураг, шуугианаас зураг, тэгээд ботыг хакердах. Ноутбук, утсаа бэлдчих.</a:t>
+За, сайн байцгаана уу залуусаа! AEPA-гийн 3-р хичээлд тавтай морил.
+Өмнөх хоёр хичээлээр бид AI-г яаж ашиглах, яаж боддогийг үзсэн. Өнөөдөр бол бүр дотор нь орно. AI яаж бүтдэг вэ гэдгийг яриад өнгөрөхгүй, гараараа хийж үзнэ.
+Өнөөдөр лекц бага, дасгал их. Дөрвөн станц бий: AI сургах, утгын газрын зураг, шуугианаас зураг, тэгээд ботыг хакердах. Ноутбук, утсаа бэлдчих.</a:t>
             </a:r>
             <a:endParaRPr lang="en-US" dirty="0"/>
           </a:p>

</xml_diff>

<commit_message>
Session 3: fix rock-paper-scissors wording in notes
Co-Authored-By: Claude Opus 5.5 <noreply@anthropic.com>
</commit_message>
<xml_diff>
--- a/session-3/AEPA-Session-3.pptx
+++ b/session-3/AEPA-Session-3.pptx
@@ -124,38 +124,38 @@
   <p:extLst>
     <p:ext uri="{521415D9-36F7-43E2-AB2F-B90AF26B5E84}">
       <p14:sectionLst xmlns:p14="http://schemas.microsoft.com/office/powerpoint/2010/main">
-        <p14:section name="Intro" id="{ed49f4a8-7f90-417d-3895-ba2b549c9515}">
+        <p14:section name="Intro" id="{c05e4a37-b06d-a1e4-d2af-1e23537da6a0}">
           <p14:sldIdLst>
             <p14:sldId id="256"/>
             <p14:sldId id="257"/>
             <p14:sldId id="258"/>
           </p14:sldIdLst>
         </p14:section>
-        <p14:section name="How models are trained" id="{bd7269f6-331c-f715-01b9-965b4f54d487}">
+        <p14:section name="How models are trained" id="{7deb8796-a66f-ae9f-b582-19631537efed}">
           <p14:sldIdLst>
             <p14:sldId id="259"/>
             <p14:sldId id="260"/>
           </p14:sldIdLst>
         </p14:section>
-        <p14:section name="Station 1: Train a model" id="{313a47e2-0d96-3d33-21f7-466d1d25514e}">
+        <p14:section name="Station 1: Train a model" id="{bb09e9f2-700f-27a1-7cdc-ac0af450764f}">
           <p14:sldIdLst>
             <p14:sldId id="261"/>
             <p14:sldId id="262"/>
           </p14:sldIdLst>
         </p14:section>
-        <p14:section name="Station 2: Map meaning" id="{7b0c9ed1-82b4-9425-fc33-02cee6e025a0}">
+        <p14:section name="Station 2: Map meaning" id="{47ed7df2-d6b8-a943-decd-35d129a4b019}">
           <p14:sldIdLst>
             <p14:sldId id="263"/>
             <p14:sldId id="264"/>
           </p14:sldIdLst>
         </p14:section>
-        <p14:section name="Station 3: Noise to image" id="{6df41c92-0067-fc8e-4d9c-ea8d563e2749}">
+        <p14:section name="Station 3: Noise to image" id="{88a8e819-5450-9afb-7a8d-779fedfe717a}">
           <p14:sldIdLst>
             <p14:sldId id="265"/>
             <p14:sldId id="266"/>
           </p14:sldIdLst>
         </p14:section>
-        <p14:section name="Agents and security" id="{0f996dc1-7cc4-8e7a-28dc-e2b73f158a96}">
+        <p14:section name="Agents and security" id="{ea5724a0-0283-24a4-8c17-f5167f4b8495}">
           <p14:sldIdLst>
             <p14:sldId id="267"/>
             <p14:sldId id="268"/>
@@ -163,7 +163,7 @@
             <p14:sldId id="270"/>
           </p14:sldIdLst>
         </p14:section>
-        <p14:section name="Wrap-up" id="{f2a1014e-bd57-f107-398b-db83c9a91c3f}">
+        <p14:section name="Wrap-up" id="{5476bca2-c91e-2e98-3adb-1d74941a9648}">
           <p14:sldIdLst>
             <p14:sldId id="271"/>
             <p14:sldId id="272"/>
@@ -1871,7 +1871,7 @@
               <a:rPr lang="en-US" dirty="0"/>
               <a:t>[~6:00]
 За, эхний станц. Өөрсдөө нэг жижиг AI сургана. Google-ийн үнэгүй Teachable Machine гэдэг сайтыг ашиглана. Код хэрэггүй.
-Алхам нь: сайт руу ор, Image project сонго. Гурван анги үүсгэ: хадаг, хайч, цаас, эсвэл чулуу, хайч, даавуу. Анги бүрт камераар 50 орчим зураг авна. Train дарна. Тэгээд туршина.
+Алхам нь: сайт руу ор, Image project сонго. Гурван анги үүсгэ: чулуу, хайч, даавуу. Анги бүрт камераар 50 орчим зураг авна. Train дарна. Тэгээд туршина.
 [Дэлгэцэн дээр шууд хийж үзүүл, 3 минут. Тэгээд хүн бүр хийнэ, 5 минут.]
 Харж байна уу? Та нар яг одоо 1-р хичээлд ярьсан бүх алхмыг хийлээ: өгөгдөл цуглуулсан, сургасан, загвартай болсон, таамаглуулсан. ChatGPT ч ер нь ийм, зүгээр хэдэн тэрбум дахин том.</a:t>
             </a:r>

</xml_diff>